<commit_message>
wavelet_coupling: DMN feature comparison — infraslow, PLV, combined
DMN marginally decodable with DWT+stats (r=0.10, p=0.04) — first positive
cross-subject DMN result. Infraslow (0.01 Hz) and PLV connectivity don't
help. DWT+stats at 1-40 Hz remains best for all targets.

Updated PPT to 11 slides with full picture: CEN r=0.18, PDA r=0.16,
DMN r=0.10. Practical recommendation: feed back CEN or PDA directly.

Co-Authored-By: Claude Sonnet 4.6 <noreply@anthropic.com>
</commit_message>
<xml_diff>
--- a/analysis/fingerprint/wavelet_coupling/wavelet_coupling_results.pptx
+++ b/analysis/fingerprint/wavelet_coupling/wavelet_coupling_results.pptx
@@ -13,6 +13,9 @@
     <p:sldId id="261" r:id="rId12"/>
     <p:sldId id="262" r:id="rId13"/>
     <p:sldId id="263" r:id="rId14"/>
+    <p:sldId id="264" r:id="rId15"/>
+    <p:sldId id="265" r:id="rId16"/>
+    <p:sldId id="266" r:id="rId17"/>
   </p:sldIdLst>
   <p:sldSz cx="12191695" cy="6858000" type="screen4x3"/>
   <p:notesSz cx="6858000" cy="9144000"/>
@@ -3238,6 +3241,725 @@
 </p:sld>
 </file>
 
+<file path=ppt/slides/slide10.xml><?xml version="1.0" encoding="utf-8"?>
+<p:sld xmlns:a="http://schemas.openxmlformats.org/drawingml/2006/main" xmlns:p="http://schemas.openxmlformats.org/presentationml/2006/main" xmlns:r="http://schemas.openxmlformats.org/officeDocument/2006/relationships">
+  <p:cSld>
+    <p:bg>
+      <p:bgPr>
+        <a:solidFill>
+          <a:srgbClr val="FFFFFF"/>
+        </a:solidFill>
+        <a:effectLst/>
+      </p:bgPr>
+    </p:bg>
+    <p:spTree>
+      <p:nvGrpSpPr>
+        <p:cNvPr id="1" name=""/>
+        <p:cNvGrpSpPr/>
+        <p:nvPr/>
+      </p:nvGrpSpPr>
+      <p:grpSpPr/>
+      <p:sp>
+        <p:nvSpPr>
+          <p:cNvPr id="2" name="TextBox 1"/>
+          <p:cNvSpPr txBox="1"/>
+          <p:nvPr/>
+        </p:nvSpPr>
+        <p:spPr>
+          <a:xfrm>
+            <a:off x="457200" y="274320"/>
+            <a:ext cx="10972800" cy="640080"/>
+          </a:xfrm>
+          <a:prstGeom prst="rect">
+            <a:avLst/>
+          </a:prstGeom>
+          <a:noFill/>
+        </p:spPr>
+        <p:txBody>
+          <a:bodyPr wrap="square">
+            <a:spAutoFit/>
+          </a:bodyPr>
+          <a:lstStyle/>
+          <a:p>
+            <a:pPr algn="l">
+              <a:defRPr sz="2800" b="1">
+                <a:solidFill>
+                  <a:srgbClr val="2C5F8A"/>
+                </a:solidFill>
+                <a:latin typeface="Calibri"/>
+              </a:defRPr>
+            </a:pPr>
+            <a:r>
+              <a:t>DMN Decoding: Full Results Table</a:t>
+            </a:r>
+          </a:p>
+        </p:txBody>
+      </p:sp>
+      <p:sp>
+        <p:nvSpPr>
+          <p:cNvPr id="3" name="TextBox 2"/>
+          <p:cNvSpPr txBox="1"/>
+          <p:nvPr/>
+        </p:nvSpPr>
+        <p:spPr>
+          <a:xfrm>
+            <a:off x="914400" y="1188720"/>
+            <a:ext cx="10058400" cy="5486400"/>
+          </a:xfrm>
+          <a:prstGeom prst="rect">
+            <a:avLst/>
+          </a:prstGeom>
+          <a:noFill/>
+        </p:spPr>
+        <p:txBody>
+          <a:bodyPr wrap="square">
+            <a:spAutoFit/>
+          </a:bodyPr>
+          <a:lstStyle/>
+          <a:p>
+            <a:pPr>
+              <a:spcAft>
+                <a:spcPts val="560"/>
+              </a:spcAft>
+              <a:defRPr sz="1400">
+                <a:solidFill>
+                  <a:srgbClr val="2C2C2C"/>
+                </a:solidFill>
+                <a:latin typeface="Calibri"/>
+              </a:defRPr>
+            </a:pPr>
+            <a:r>
+              <a:t>GSR'd DMN (the hard target):</a:t>
+            </a:r>
+          </a:p>
+          <a:p>
+            <a:pPr>
+              <a:spcAft>
+                <a:spcPts val="560"/>
+              </a:spcAft>
+              <a:defRPr sz="1400">
+                <a:solidFill>
+                  <a:srgbClr val="2C2C2C"/>
+                </a:solidFill>
+                <a:latin typeface="Calibri"/>
+              </a:defRPr>
+            </a:pPr>
+          </a:p>
+          <a:p>
+            <a:pPr>
+              <a:spcAft>
+                <a:spcPts val="560"/>
+              </a:spcAft>
+              <a:defRPr sz="1400">
+                <a:solidFill>
+                  <a:srgbClr val="2C2C2C"/>
+                </a:solidFill>
+                <a:latin typeface="Calibri"/>
+              </a:defRPr>
+            </a:pPr>
+            <a:r>
+              <a:t>  Method                Cross-subj r    p           n</a:t>
+            </a:r>
+          </a:p>
+          <a:p>
+            <a:pPr>
+              <a:spcAft>
+                <a:spcPts val="560"/>
+              </a:spcAft>
+              <a:defRPr sz="1400">
+                <a:solidFill>
+                  <a:srgbClr val="2C2C2C"/>
+                </a:solidFill>
+                <a:latin typeface="Calibri"/>
+              </a:defRPr>
+            </a:pPr>
+            <a:r>
+              <a:t>  ─────────────────────────────────────────────────────</a:t>
+            </a:r>
+          </a:p>
+          <a:p>
+            <a:pPr>
+              <a:spcAft>
+                <a:spcPts val="560"/>
+              </a:spcAft>
+              <a:defRPr sz="1400">
+                <a:solidFill>
+                  <a:srgbClr val="2C2C2C"/>
+                </a:solidFill>
+                <a:latin typeface="Calibri"/>
+              </a:defRPr>
+            </a:pPr>
+            <a:r>
+              <a:t>  DWT+stats (1-40Hz)    +0.099          0.04  *     17</a:t>
+            </a:r>
+          </a:p>
+          <a:p>
+            <a:pPr>
+              <a:spcAft>
+                <a:spcPts val="560"/>
+              </a:spcAft>
+              <a:defRPr sz="1400">
+                <a:solidFill>
+                  <a:srgbClr val="2C2C2C"/>
+                </a:solidFill>
+                <a:latin typeface="Calibri"/>
+              </a:defRPr>
+            </a:pPr>
+            <a:r>
+              <a:t>  DWT+stats IS          +0.093          *           17</a:t>
+            </a:r>
+          </a:p>
+          <a:p>
+            <a:pPr>
+              <a:spcAft>
+                <a:spcPts val="560"/>
+              </a:spcAft>
+              <a:defRPr sz="1400">
+                <a:solidFill>
+                  <a:srgbClr val="2C2C2C"/>
+                </a:solidFill>
+                <a:latin typeface="Calibri"/>
+              </a:defRPr>
+            </a:pPr>
+            <a:r>
+              <a:t>  PLV (1-40Hz)          +0.014          n.s.        17</a:t>
+            </a:r>
+          </a:p>
+          <a:p>
+            <a:pPr>
+              <a:spcAft>
+                <a:spcPts val="560"/>
+              </a:spcAft>
+              <a:defRPr sz="1400">
+                <a:solidFill>
+                  <a:srgbClr val="2C2C2C"/>
+                </a:solidFill>
+                <a:latin typeface="Calibri"/>
+              </a:defRPr>
+            </a:pPr>
+            <a:r>
+              <a:t>  PLV IS                −0.018          n.s.        17</a:t>
+            </a:r>
+          </a:p>
+          <a:p>
+            <a:pPr>
+              <a:spcAft>
+                <a:spcPts val="560"/>
+              </a:spcAft>
+              <a:defRPr sz="1400">
+                <a:solidFill>
+                  <a:srgbClr val="2C2C2C"/>
+                </a:solidFill>
+                <a:latin typeface="Calibri"/>
+              </a:defRPr>
+            </a:pPr>
+            <a:r>
+              <a:t>  Combined              +0.005          n.s.        17</a:t>
+            </a:r>
+          </a:p>
+          <a:p>
+            <a:pPr>
+              <a:spcAft>
+                <a:spcPts val="560"/>
+              </a:spcAft>
+              <a:defRPr sz="1400">
+                <a:solidFill>
+                  <a:srgbClr val="2C2C2C"/>
+                </a:solidFill>
+                <a:latin typeface="Calibri"/>
+              </a:defRPr>
+            </a:pPr>
+            <a:r>
+              <a:t>  Combined IS           −0.006          n.s.        17</a:t>
+            </a:r>
+          </a:p>
+          <a:p>
+            <a:pPr>
+              <a:spcAft>
+                <a:spcPts val="560"/>
+              </a:spcAft>
+              <a:defRPr sz="1400">
+                <a:solidFill>
+                  <a:srgbClr val="2C2C2C"/>
+                </a:solidFill>
+                <a:latin typeface="Calibri"/>
+              </a:defRPr>
+            </a:pPr>
+          </a:p>
+          <a:p>
+            <a:pPr>
+              <a:spcAft>
+                <a:spcPts val="560"/>
+              </a:spcAft>
+              <a:defRPr sz="1400">
+                <a:solidFill>
+                  <a:srgbClr val="2C2C2C"/>
+                </a:solidFill>
+                <a:latin typeface="Calibri"/>
+              </a:defRPr>
+            </a:pPr>
+            <a:r>
+              <a:t>For comparison — GSR'd CEN with same methods:</a:t>
+            </a:r>
+          </a:p>
+          <a:p>
+            <a:pPr>
+              <a:spcAft>
+                <a:spcPts val="560"/>
+              </a:spcAft>
+              <a:defRPr sz="1400">
+                <a:solidFill>
+                  <a:srgbClr val="2C2C2C"/>
+                </a:solidFill>
+                <a:latin typeface="Calibri"/>
+              </a:defRPr>
+            </a:pPr>
+          </a:p>
+          <a:p>
+            <a:pPr>
+              <a:spcAft>
+                <a:spcPts val="560"/>
+              </a:spcAft>
+              <a:defRPr sz="1400">
+                <a:solidFill>
+                  <a:srgbClr val="2C2C2C"/>
+                </a:solidFill>
+                <a:latin typeface="Calibri"/>
+              </a:defRPr>
+            </a:pPr>
+            <a:r>
+              <a:t>  DWT+stats (1-40Hz)    +0.179          0.001 **    17   ← still best</a:t>
+            </a:r>
+          </a:p>
+          <a:p>
+            <a:pPr>
+              <a:spcAft>
+                <a:spcPts val="560"/>
+              </a:spcAft>
+              <a:defRPr sz="1400">
+                <a:solidFill>
+                  <a:srgbClr val="2C2C2C"/>
+                </a:solidFill>
+                <a:latin typeface="Calibri"/>
+              </a:defRPr>
+            </a:pPr>
+            <a:r>
+              <a:t>  DWT+stats IS          +0.177          **          17</a:t>
+            </a:r>
+          </a:p>
+          <a:p>
+            <a:pPr>
+              <a:spcAft>
+                <a:spcPts val="560"/>
+              </a:spcAft>
+              <a:defRPr sz="1400">
+                <a:solidFill>
+                  <a:srgbClr val="2C2C2C"/>
+                </a:solidFill>
+                <a:latin typeface="Calibri"/>
+              </a:defRPr>
+            </a:pPr>
+            <a:r>
+              <a:t>  PLV                   +0.073          *           17</a:t>
+            </a:r>
+          </a:p>
+          <a:p>
+            <a:pPr>
+              <a:spcAft>
+                <a:spcPts val="560"/>
+              </a:spcAft>
+              <a:defRPr sz="1400">
+                <a:solidFill>
+                  <a:srgbClr val="2C2C2C"/>
+                </a:solidFill>
+                <a:latin typeface="Calibri"/>
+              </a:defRPr>
+            </a:pPr>
+            <a:r>
+              <a:t>  Combined              +0.130          **          17</a:t>
+            </a:r>
+          </a:p>
+        </p:txBody>
+      </p:sp>
+    </p:spTree>
+  </p:cSld>
+  <p:clrMapOvr>
+    <a:masterClrMapping/>
+  </p:clrMapOvr>
+</p:sld>
+</file>
+
+<file path=ppt/slides/slide11.xml><?xml version="1.0" encoding="utf-8"?>
+<p:sld xmlns:a="http://schemas.openxmlformats.org/drawingml/2006/main" xmlns:p="http://schemas.openxmlformats.org/presentationml/2006/main" xmlns:r="http://schemas.openxmlformats.org/officeDocument/2006/relationships">
+  <p:cSld>
+    <p:bg>
+      <p:bgPr>
+        <a:solidFill>
+          <a:srgbClr val="FFFFFF"/>
+        </a:solidFill>
+        <a:effectLst/>
+      </p:bgPr>
+    </p:bg>
+    <p:spTree>
+      <p:nvGrpSpPr>
+        <p:cNvPr id="1" name=""/>
+        <p:cNvGrpSpPr/>
+        <p:nvPr/>
+      </p:nvGrpSpPr>
+      <p:grpSpPr/>
+      <p:sp>
+        <p:nvSpPr>
+          <p:cNvPr id="2" name="TextBox 1"/>
+          <p:cNvSpPr txBox="1"/>
+          <p:nvPr/>
+        </p:nvSpPr>
+        <p:spPr>
+          <a:xfrm>
+            <a:off x="457200" y="274320"/>
+            <a:ext cx="10972800" cy="640080"/>
+          </a:xfrm>
+          <a:prstGeom prst="rect">
+            <a:avLst/>
+          </a:prstGeom>
+          <a:noFill/>
+        </p:spPr>
+        <p:txBody>
+          <a:bodyPr wrap="square">
+            <a:spAutoFit/>
+          </a:bodyPr>
+          <a:lstStyle/>
+          <a:p>
+            <a:pPr algn="l">
+              <a:defRPr sz="2800" b="1">
+                <a:solidFill>
+                  <a:srgbClr val="38761D"/>
+                </a:solidFill>
+                <a:latin typeface="Calibri"/>
+              </a:defRPr>
+            </a:pPr>
+            <a:r>
+              <a:t>Implications for EEG-Only Neurofeedback</a:t>
+            </a:r>
+          </a:p>
+        </p:txBody>
+      </p:sp>
+      <p:sp>
+        <p:nvSpPr>
+          <p:cNvPr id="3" name="TextBox 2"/>
+          <p:cNvSpPr txBox="1"/>
+          <p:nvPr/>
+        </p:nvSpPr>
+        <p:spPr>
+          <a:xfrm>
+            <a:off x="457200" y="1188720"/>
+            <a:ext cx="10058400" cy="5029200"/>
+          </a:xfrm>
+          <a:prstGeom prst="rect">
+            <a:avLst/>
+          </a:prstGeom>
+          <a:noFill/>
+        </p:spPr>
+        <p:txBody>
+          <a:bodyPr wrap="square">
+            <a:spAutoFit/>
+          </a:bodyPr>
+          <a:lstStyle/>
+          <a:p>
+            <a:pPr>
+              <a:spcAft>
+                <a:spcPts val="600"/>
+              </a:spcAft>
+              <a:defRPr sz="1500">
+                <a:solidFill>
+                  <a:srgbClr val="2C2C2C"/>
+                </a:solidFill>
+                <a:latin typeface="Calibri"/>
+              </a:defRPr>
+            </a:pPr>
+            <a:r>
+              <a:t>The original NF paradigm feeds back PDA = CEN − DMN</a:t>
+            </a:r>
+          </a:p>
+          <a:p>
+            <a:pPr>
+              <a:spcAft>
+                <a:spcPts val="600"/>
+              </a:spcAft>
+              <a:defRPr sz="1500">
+                <a:solidFill>
+                  <a:srgbClr val="2C2C2C"/>
+                </a:solidFill>
+                <a:latin typeface="Calibri"/>
+              </a:defRPr>
+            </a:pPr>
+          </a:p>
+          <a:p>
+            <a:pPr>
+              <a:spcAft>
+                <a:spcPts val="600"/>
+              </a:spcAft>
+              <a:defRPr sz="1500">
+                <a:solidFill>
+                  <a:srgbClr val="2C2C2C"/>
+                </a:solidFill>
+                <a:latin typeface="Calibri"/>
+              </a:defRPr>
+            </a:pPr>
+            <a:r>
+              <a:t>For EEG-only NF, three options:</a:t>
+            </a:r>
+          </a:p>
+          <a:p>
+            <a:pPr>
+              <a:spcAft>
+                <a:spcPts val="600"/>
+              </a:spcAft>
+              <a:defRPr sz="1500">
+                <a:solidFill>
+                  <a:srgbClr val="2C2C2C"/>
+                </a:solidFill>
+                <a:latin typeface="Calibri"/>
+              </a:defRPr>
+            </a:pPr>
+          </a:p>
+          <a:p>
+            <a:pPr>
+              <a:spcAft>
+                <a:spcPts val="600"/>
+              </a:spcAft>
+              <a:defRPr sz="1500">
+                <a:solidFill>
+                  <a:srgbClr val="2C2C2C"/>
+                </a:solidFill>
+                <a:latin typeface="Calibri"/>
+              </a:defRPr>
+            </a:pPr>
+            <a:r>
+              <a:t>  Option A: EEG-PDA = predicted CEN − predicted DMN</a:t>
+            </a:r>
+          </a:p>
+          <a:p>
+            <a:pPr>
+              <a:spcAft>
+                <a:spcPts val="600"/>
+              </a:spcAft>
+              <a:defRPr sz="1500">
+                <a:solidFill>
+                  <a:srgbClr val="2C2C2C"/>
+                </a:solidFill>
+                <a:latin typeface="Calibri"/>
+              </a:defRPr>
+            </a:pPr>
+            <a:r>
+              <a:t>     CEN: r=0.18, DMN: r=0.10 → subtraction adds noise from weak DMN decoder</a:t>
+            </a:r>
+          </a:p>
+          <a:p>
+            <a:pPr>
+              <a:spcAft>
+                <a:spcPts val="600"/>
+              </a:spcAft>
+              <a:defRPr sz="1500">
+                <a:solidFill>
+                  <a:srgbClr val="2C2C2C"/>
+                </a:solidFill>
+                <a:latin typeface="Calibri"/>
+              </a:defRPr>
+            </a:pPr>
+          </a:p>
+          <a:p>
+            <a:pPr>
+              <a:spcAft>
+                <a:spcPts val="600"/>
+              </a:spcAft>
+              <a:defRPr sz="1500">
+                <a:solidFill>
+                  <a:srgbClr val="2C2C2C"/>
+                </a:solidFill>
+                <a:latin typeface="Calibri"/>
+              </a:defRPr>
+            </a:pPr>
+            <a:r>
+              <a:t>  Option B: Decode PDA directly (CEN−DMN as single target)</a:t>
+            </a:r>
+          </a:p>
+          <a:p>
+            <a:pPr>
+              <a:spcAft>
+                <a:spcPts val="600"/>
+              </a:spcAft>
+              <a:defRPr sz="1500">
+                <a:solidFill>
+                  <a:srgbClr val="2C2C2C"/>
+                </a:solidFill>
+                <a:latin typeface="Calibri"/>
+              </a:defRPr>
+            </a:pPr>
+            <a:r>
+              <a:t>     r = 0.155 cross-subject — the model learns the difference pattern directly</a:t>
+            </a:r>
+          </a:p>
+          <a:p>
+            <a:pPr>
+              <a:spcAft>
+                <a:spcPts val="600"/>
+              </a:spcAft>
+              <a:defRPr sz="1500">
+                <a:solidFill>
+                  <a:srgbClr val="2C2C2C"/>
+                </a:solidFill>
+                <a:latin typeface="Calibri"/>
+              </a:defRPr>
+            </a:pPr>
+            <a:r>
+              <a:t>     Avoids combining two noisy estimates</a:t>
+            </a:r>
+          </a:p>
+          <a:p>
+            <a:pPr>
+              <a:spcAft>
+                <a:spcPts val="600"/>
+              </a:spcAft>
+              <a:defRPr sz="1500">
+                <a:solidFill>
+                  <a:srgbClr val="2C2C2C"/>
+                </a:solidFill>
+                <a:latin typeface="Calibri"/>
+              </a:defRPr>
+            </a:pPr>
+          </a:p>
+          <a:p>
+            <a:pPr>
+              <a:spcAft>
+                <a:spcPts val="600"/>
+              </a:spcAft>
+              <a:defRPr sz="1500">
+                <a:solidFill>
+                  <a:srgbClr val="2C2C2C"/>
+                </a:solidFill>
+                <a:latin typeface="Calibri"/>
+              </a:defRPr>
+            </a:pPr>
+            <a:r>
+              <a:t>  Option C: Feed back CEN only</a:t>
+            </a:r>
+          </a:p>
+          <a:p>
+            <a:pPr>
+              <a:spcAft>
+                <a:spcPts val="600"/>
+              </a:spcAft>
+              <a:defRPr sz="1500">
+                <a:solidFill>
+                  <a:srgbClr val="2C2C2C"/>
+                </a:solidFill>
+                <a:latin typeface="Calibri"/>
+              </a:defRPr>
+            </a:pPr>
+            <a:r>
+              <a:t>     r = 0.179 cross-subject — strongest single decoder</a:t>
+            </a:r>
+          </a:p>
+          <a:p>
+            <a:pPr>
+              <a:spcAft>
+                <a:spcPts val="600"/>
+              </a:spcAft>
+              <a:defRPr sz="1500">
+                <a:solidFill>
+                  <a:srgbClr val="2C2C2C"/>
+                </a:solidFill>
+                <a:latin typeface="Calibri"/>
+              </a:defRPr>
+            </a:pPr>
+            <a:r>
+              <a:t>     CEN up-regulation is the active component; DMN suppression follows passively</a:t>
+            </a:r>
+          </a:p>
+          <a:p>
+            <a:pPr>
+              <a:spcAft>
+                <a:spcPts val="600"/>
+              </a:spcAft>
+              <a:defRPr sz="1500">
+                <a:solidFill>
+                  <a:srgbClr val="2C2C2C"/>
+                </a:solidFill>
+                <a:latin typeface="Calibri"/>
+              </a:defRPr>
+            </a:pPr>
+          </a:p>
+          <a:p>
+            <a:pPr>
+              <a:spcAft>
+                <a:spcPts val="600"/>
+              </a:spcAft>
+              <a:defRPr sz="1500">
+                <a:solidFill>
+                  <a:srgbClr val="2C2C2C"/>
+                </a:solidFill>
+                <a:latin typeface="Calibri"/>
+              </a:defRPr>
+            </a:pPr>
+            <a:r>
+              <a:t>Recommendation: Option B (direct PDA) for parity with fMRI paradigm,</a:t>
+            </a:r>
+          </a:p>
+          <a:p>
+            <a:pPr>
+              <a:spcAft>
+                <a:spcPts val="600"/>
+              </a:spcAft>
+              <a:defRPr sz="1500">
+                <a:solidFill>
+                  <a:srgbClr val="2C2C2C"/>
+                </a:solidFill>
+                <a:latin typeface="Calibri"/>
+              </a:defRPr>
+            </a:pPr>
+            <a:r>
+              <a:t>Option C (CEN only) as practical fallback with stronger signal</a:t>
+            </a:r>
+          </a:p>
+          <a:p>
+            <a:pPr>
+              <a:spcAft>
+                <a:spcPts val="600"/>
+              </a:spcAft>
+              <a:defRPr sz="1500">
+                <a:solidFill>
+                  <a:srgbClr val="2C2C2C"/>
+                </a:solidFill>
+                <a:latin typeface="Calibri"/>
+              </a:defRPr>
+            </a:pPr>
+          </a:p>
+          <a:p>
+            <a:pPr>
+              <a:spcAft>
+                <a:spcPts val="600"/>
+              </a:spcAft>
+              <a:defRPr sz="1500">
+                <a:solidFill>
+                  <a:srgbClr val="2C2C2C"/>
+                </a:solidFill>
+                <a:latin typeface="Calibri"/>
+              </a:defRPr>
+            </a:pPr>
+            <a:r>
+              <a:t>DMN at r=0.10 is a real but weak signal — needs source localization to improve</a:t>
+            </a:r>
+          </a:p>
+        </p:txBody>
+      </p:sp>
+    </p:spTree>
+  </p:cSld>
+  <p:clrMapOvr>
+    <a:masterClrMapping/>
+  </p:clrMapOvr>
+</p:sld>
+</file>
+
 <file path=ppt/slides/slide2.xml><?xml version="1.0" encoding="utf-8"?>
 <p:sld xmlns:a="http://schemas.openxmlformats.org/drawingml/2006/main" xmlns:p="http://schemas.openxmlformats.org/presentationml/2006/main" xmlns:r="http://schemas.openxmlformats.org/officeDocument/2006/relationships">
   <p:cSld>
@@ -4792,7 +5514,7 @@
         </p:nvSpPr>
         <p:spPr>
           <a:xfrm>
-            <a:off x="731520" y="731520"/>
+            <a:off x="731520" y="548640"/>
             <a:ext cx="10515600" cy="731520"/>
           </a:xfrm>
           <a:prstGeom prst="rect">
@@ -4815,7 +5537,7 @@
               </a:defRPr>
             </a:pPr>
             <a:r>
-              <a:t>Bottom Line</a:t>
+              <a:t>Full Picture</a:t>
             </a:r>
           </a:p>
         </p:txBody>
@@ -4828,8 +5550,8 @@
         </p:nvSpPr>
         <p:spPr>
           <a:xfrm>
-            <a:off x="914400" y="1828800"/>
-            <a:ext cx="10058400" cy="4572000"/>
+            <a:off x="914400" y="1463040"/>
+            <a:ext cx="10058400" cy="5029200"/>
           </a:xfrm>
           <a:prstGeom prst="rect">
             <a:avLst/>
@@ -4844,9 +5566,9 @@
           <a:p>
             <a:pPr algn="ctr">
               <a:spcAft>
-                <a:spcPts val="720"/>
-              </a:spcAft>
-              <a:defRPr sz="1800">
+                <a:spcPts val="680"/>
+              </a:spcAft>
+              <a:defRPr sz="1700">
                 <a:solidFill>
                   <a:srgbClr val="DDDDDD"/>
                 </a:solidFill>
@@ -4854,44 +5576,44 @@
               </a:defRPr>
             </a:pPr>
             <a:r>
-              <a:t>DWT statistical features (energy, mean, std, entropy) substantially improve</a:t>
+              <a:t>DWT statistical features are the best EEG features for fMRI network decoding</a:t>
             </a:r>
           </a:p>
           <a:p>
             <a:pPr algn="ctr">
               <a:spcAft>
-                <a:spcPts val="720"/>
-              </a:spcAft>
-              <a:defRPr sz="1800">
+                <a:spcPts val="680"/>
+              </a:spcAft>
+              <a:defRPr sz="1700">
                 <a:solidFill>
                   <a:srgbClr val="DDDDDD"/>
                 </a:solidFill>
                 <a:latin typeface="Calibri"/>
               </a:defRPr>
             </a:pPr>
-            <a:r>
-              <a:t>cross-subject EEG → fMRI decoding over Hilbert envelope power</a:t>
-            </a:r>
           </a:p>
           <a:p>
             <a:pPr algn="ctr">
               <a:spcAft>
-                <a:spcPts val="720"/>
-              </a:spcAft>
-              <a:defRPr sz="1800">
+                <a:spcPts val="680"/>
+              </a:spcAft>
+              <a:defRPr sz="1700">
                 <a:solidFill>
                   <a:srgbClr val="DDDDDD"/>
                 </a:solidFill>
                 <a:latin typeface="Calibri"/>
               </a:defRPr>
             </a:pPr>
+            <a:r>
+              <a:t>Cross-subject (no fMRI, no calibration):</a:t>
+            </a:r>
           </a:p>
           <a:p>
             <a:pPr algn="ctr">
               <a:spcAft>
-                <a:spcPts val="720"/>
-              </a:spcAft>
-              <a:defRPr sz="1800">
+                <a:spcPts val="680"/>
+              </a:spcAft>
+              <a:defRPr sz="1700">
                 <a:solidFill>
                   <a:srgbClr val="DDDDDD"/>
                 </a:solidFill>
@@ -4899,15 +5621,15 @@
               </a:defRPr>
             </a:pPr>
             <a:r>
-              <a:t>GSR CEN cross-subject:  r = 0.179  (p = 0.001)  —  +56% vs Hilbert</a:t>
+              <a:t>  GSR'd CEN:  r = 0.179  (p = 0.001)  — strong, actionable</a:t>
             </a:r>
           </a:p>
           <a:p>
             <a:pPr algn="ctr">
               <a:spcAft>
-                <a:spcPts val="720"/>
-              </a:spcAft>
-              <a:defRPr sz="1800">
+                <a:spcPts val="680"/>
+              </a:spcAft>
+              <a:defRPr sz="1700">
                 <a:solidFill>
                   <a:srgbClr val="DDDDDD"/>
                 </a:solidFill>
@@ -4915,44 +5637,44 @@
               </a:defRPr>
             </a:pPr>
             <a:r>
-              <a:t>PDA cross-subject:       r = 0.155  (p = 0.006)  —  +47% vs Hilbert</a:t>
+              <a:t>  PDA:            r = 0.155  (p = 0.006)  — viable for NF</a:t>
             </a:r>
           </a:p>
           <a:p>
             <a:pPr algn="ctr">
               <a:spcAft>
-                <a:spcPts val="720"/>
-              </a:spcAft>
-              <a:defRPr sz="1800">
+                <a:spcPts val="680"/>
+              </a:spcAft>
+              <a:defRPr sz="1700">
                 <a:solidFill>
                   <a:srgbClr val="DDDDDD"/>
                 </a:solidFill>
                 <a:latin typeface="Calibri"/>
               </a:defRPr>
             </a:pPr>
+            <a:r>
+              <a:t>  GSR'd DMN:  r = 0.099  (p = 0.04)    — marginal, needs source space</a:t>
+            </a:r>
           </a:p>
           <a:p>
             <a:pPr algn="ctr">
               <a:spcAft>
-                <a:spcPts val="720"/>
-              </a:spcAft>
-              <a:defRPr sz="1800">
+                <a:spcPts val="680"/>
+              </a:spcAft>
+              <a:defRPr sz="1700">
                 <a:solidFill>
                   <a:srgbClr val="DDDDDD"/>
                 </a:solidFill>
                 <a:latin typeface="Calibri"/>
               </a:defRPr>
             </a:pPr>
-            <a:r>
-              <a:t>The improvement comes from STATISTICAL features, not the wavelet decomposition —</a:t>
-            </a:r>
           </a:p>
           <a:p>
             <a:pPr algn="ctr">
               <a:spcAft>
-                <a:spcPts val="720"/>
-              </a:spcAft>
-              <a:defRPr sz="1800">
+                <a:spcPts val="680"/>
+              </a:spcAft>
+              <a:defRPr sz="1700">
                 <a:solidFill>
                   <a:srgbClr val="DDDDDD"/>
                 </a:solidFill>
@@ -4960,44 +5682,44 @@
               </a:defRPr>
             </a:pPr>
             <a:r>
-              <a:t>Morlet CWT and DWT power-only match Hilbert at 155 features</a:t>
+              <a:t>What works:   wavelet stats (std, entropy) &gt; raw power</a:t>
             </a:r>
           </a:p>
           <a:p>
             <a:pPr algn="ctr">
               <a:spcAft>
-                <a:spcPts val="720"/>
-              </a:spcAft>
-              <a:defRPr sz="1800">
+                <a:spcPts val="680"/>
+              </a:spcAft>
+              <a:defRPr sz="1700">
                 <a:solidFill>
                   <a:srgbClr val="DDDDDD"/>
                 </a:solidFill>
                 <a:latin typeface="Calibri"/>
               </a:defRPr>
             </a:pPr>
+            <a:r>
+              <a:t>What doesn't: infraslow bands, PLV connectivity, Morlet CWT</a:t>
+            </a:r>
           </a:p>
           <a:p>
             <a:pPr algn="ctr">
               <a:spcAft>
-                <a:spcPts val="720"/>
-              </a:spcAft>
-              <a:defRPr sz="1800">
+                <a:spcPts val="680"/>
+              </a:spcAft>
+              <a:defRPr sz="1700">
                 <a:solidFill>
                   <a:srgbClr val="DDDDDD"/>
                 </a:solidFill>
                 <a:latin typeface="Calibri"/>
               </a:defRPr>
             </a:pPr>
-            <a:r>
-              <a:t>Within-TR variability (std) and complexity (entropy) of wavelet coefficients</a:t>
-            </a:r>
           </a:p>
           <a:p>
             <a:pPr algn="ctr">
               <a:spcAft>
-                <a:spcPts val="720"/>
-              </a:spcAft>
-              <a:defRPr sz="1800">
+                <a:spcPts val="680"/>
+              </a:spcAft>
+              <a:defRPr sz="1700">
                 <a:solidFill>
                   <a:srgbClr val="DDDDDD"/>
                 </a:solidFill>
@@ -5005,28 +5727,31 @@
               </a:defRPr>
             </a:pPr>
             <a:r>
-              <a:t>carry network-specific information that amplitude envelope averages out</a:t>
+              <a:t>Practical pipeline for EEG-only CEN neurofeedback:</a:t>
             </a:r>
           </a:p>
           <a:p>
             <a:pPr algn="ctr">
               <a:spcAft>
-                <a:spcPts val="720"/>
-              </a:spcAft>
-              <a:defRPr sz="1800">
+                <a:spcPts val="680"/>
+              </a:spcAft>
+              <a:defRPr sz="1700">
                 <a:solidFill>
                   <a:srgbClr val="DDDDDD"/>
                 </a:solidFill>
                 <a:latin typeface="Calibri"/>
               </a:defRPr>
             </a:pPr>
+            <a:r>
+              <a:t>  DWT db4 + stats → CAR → group Ridge model</a:t>
+            </a:r>
           </a:p>
           <a:p>
             <a:pPr algn="ctr">
               <a:spcAft>
-                <a:spcPts val="720"/>
-              </a:spcAft>
-              <a:defRPr sz="1800">
+                <a:spcPts val="680"/>
+              </a:spcAft>
+              <a:defRPr sz="1700">
                 <a:solidFill>
                   <a:srgbClr val="DDDDDD"/>
                 </a:solidFill>
@@ -5034,7 +5759,23 @@
               </a:defRPr>
             </a:pPr>
             <a:r>
-              <a:t>Recommended pipeline: DWT db4 + stats → CAR → Ridge + pseudo-target calibration</a:t>
+              <a:t>  + 1-run pseudo-target calibration (baseline→feedback block)</a:t>
+            </a:r>
+          </a:p>
+          <a:p>
+            <a:pPr algn="ctr">
+              <a:spcAft>
+                <a:spcPts val="680"/>
+              </a:spcAft>
+              <a:defRPr sz="1700">
+                <a:solidFill>
+                  <a:srgbClr val="DDDDDD"/>
+                </a:solidFill>
+                <a:latin typeface="Calibri"/>
+              </a:defRPr>
+            </a:pPr>
+            <a:r>
+              <a:t>  → predict CEN (or PDA) in real-time, no fMRI needed</a:t>
             </a:r>
           </a:p>
         </p:txBody>
@@ -5335,6 +6076,163 @@
             </a:pPr>
             <a:r>
               <a:t>   Unlike CWT which is O(n·m) where m = number of scales</a:t>
+            </a:r>
+          </a:p>
+        </p:txBody>
+      </p:sp>
+    </p:spTree>
+  </p:cSld>
+  <p:clrMapOvr>
+    <a:masterClrMapping/>
+  </p:clrMapOvr>
+</p:sld>
+</file>
+
+<file path=ppt/slides/slide9.xml><?xml version="1.0" encoding="utf-8"?>
+<p:sld xmlns:a="http://schemas.openxmlformats.org/drawingml/2006/main" xmlns:p="http://schemas.openxmlformats.org/presentationml/2006/main" xmlns:r="http://schemas.openxmlformats.org/officeDocument/2006/relationships">
+  <p:cSld>
+    <p:bg>
+      <p:bgPr>
+        <a:solidFill>
+          <a:srgbClr val="FFFFFF"/>
+        </a:solidFill>
+        <a:effectLst/>
+      </p:bgPr>
+    </p:bg>
+    <p:spTree>
+      <p:nvGrpSpPr>
+        <p:cNvPr id="1" name=""/>
+        <p:cNvGrpSpPr/>
+        <p:nvPr/>
+      </p:nvGrpSpPr>
+      <p:grpSpPr/>
+      <p:sp>
+        <p:nvSpPr>
+          <p:cNvPr id="2" name="TextBox 1"/>
+          <p:cNvSpPr txBox="1"/>
+          <p:nvPr/>
+        </p:nvSpPr>
+        <p:spPr>
+          <a:xfrm>
+            <a:off x="457200" y="274320"/>
+            <a:ext cx="10972800" cy="640080"/>
+          </a:xfrm>
+          <a:prstGeom prst="rect">
+            <a:avLst/>
+          </a:prstGeom>
+          <a:noFill/>
+        </p:spPr>
+        <p:txBody>
+          <a:bodyPr wrap="square">
+            <a:spAutoFit/>
+          </a:bodyPr>
+          <a:lstStyle/>
+          <a:p>
+            <a:pPr algn="l">
+              <a:defRPr sz="2800" b="1">
+                <a:solidFill>
+                  <a:srgbClr val="990000"/>
+                </a:solidFill>
+                <a:latin typeface="Calibri"/>
+              </a:defRPr>
+            </a:pPr>
+            <a:r>
+              <a:t>Can We Decode DMN? Infraslow + Connectivity Test</a:t>
+            </a:r>
+          </a:p>
+        </p:txBody>
+      </p:sp>
+      <p:pic>
+        <p:nvPicPr>
+          <p:cNvPr id="3" name="Picture 2" descr="dmn_features_comparison.png"/>
+          <p:cNvPicPr>
+            <a:picLocks noChangeAspect="1"/>
+          </p:cNvPicPr>
+          <p:nvPr/>
+        </p:nvPicPr>
+        <p:blipFill>
+          <a:blip r:embed="rId2"/>
+          <a:stretch>
+            <a:fillRect/>
+          </a:stretch>
+        </p:blipFill>
+        <p:spPr>
+          <a:xfrm>
+            <a:off x="274320" y="1005840"/>
+            <a:ext cx="11612880" cy="3516122"/>
+          </a:xfrm>
+          <a:prstGeom prst="rect">
+            <a:avLst/>
+          </a:prstGeom>
+        </p:spPr>
+      </p:pic>
+      <p:sp>
+        <p:nvSpPr>
+          <p:cNvPr id="4" name="TextBox 3"/>
+          <p:cNvSpPr txBox="1"/>
+          <p:nvPr/>
+        </p:nvSpPr>
+        <p:spPr>
+          <a:xfrm>
+            <a:off x="457200" y="4572000"/>
+            <a:ext cx="10972800" cy="2011680"/>
+          </a:xfrm>
+          <a:prstGeom prst="rect">
+            <a:avLst/>
+          </a:prstGeom>
+          <a:noFill/>
+        </p:spPr>
+        <p:txBody>
+          <a:bodyPr wrap="square">
+            <a:spAutoFit/>
+          </a:bodyPr>
+          <a:lstStyle/>
+          <a:p>
+            <a:pPr>
+              <a:spcAft>
+                <a:spcPts val="560"/>
+              </a:spcAft>
+              <a:defRPr sz="1400">
+                <a:solidFill>
+                  <a:srgbClr val="2C2C2C"/>
+                </a:solidFill>
+                <a:latin typeface="Calibri"/>
+              </a:defRPr>
+            </a:pPr>
+            <a:r>
+              <a:t>DMN is marginally decodable with DWT+stats (r=0.10, p=0.04) — first positive cross-subject DMN result.</a:t>
+            </a:r>
+          </a:p>
+          <a:p>
+            <a:pPr>
+              <a:spcAft>
+                <a:spcPts val="560"/>
+              </a:spcAft>
+              <a:defRPr sz="1400">
+                <a:solidFill>
+                  <a:srgbClr val="2C2C2C"/>
+                </a:solidFill>
+                <a:latin typeface="Calibri"/>
+              </a:defRPr>
+            </a:pPr>
+            <a:r>
+              <a:t>Infraslow (0.01 Hz) does NOT help. PLV connectivity fails cross-subject (too subject-specific).</a:t>
+            </a:r>
+          </a:p>
+          <a:p>
+            <a:pPr>
+              <a:spcAft>
+                <a:spcPts val="560"/>
+              </a:spcAft>
+              <a:defRPr sz="1400">
+                <a:solidFill>
+                  <a:srgbClr val="2C2C2C"/>
+                </a:solidFill>
+                <a:latin typeface="Calibri"/>
+              </a:defRPr>
+            </a:pPr>
+            <a:r>
+              <a:t>Adding PLV to power features dilutes the signal. DWT+stats alone remains best for all targets.</a:t>
             </a:r>
           </a:p>
         </p:txBody>

</xml_diff>